<commit_message>
Open API timeline: single bar with New (green) + Existing (blue) users
- Combined one-track timeline in program PPT and standalone Open API deck
- Milestone cards alternate above/below the unified bar
- Updated browser HTML slide to match

Co-authored-by: maiagordon-commits <maiagordon-commits@users.noreply.github.com>
</commit_message>
<xml_diff>
--- a/guesty_program_timeline.pptx
+++ b/guesty_program_timeline.pptx
@@ -3165,7 +3165,7 @@
               </a:defRPr>
             </a:pPr>
             <a:r>
-              <a:t>Jul 2026 → Mar 2027 · Click any text to edit after import</a:t>
+              <a:t>Jul 2026 → Mar 2027 · Green = New Users · Blue = Existing Users</a:t>
             </a:r>
           </a:p>
         </p:txBody>
@@ -3178,7 +3178,7 @@
         </p:nvSpPr>
         <p:spPr>
           <a:xfrm>
-            <a:off x="1234440" y="1234440"/>
+            <a:off x="1234440" y="1170432"/>
             <a:ext cx="1097280" cy="256032"/>
           </a:xfrm>
           <a:prstGeom prst="rect">
@@ -3201,7 +3201,7 @@
               </a:defRPr>
             </a:pPr>
             <a:r>
-              <a:t>Jun 2026</a:t>
+              <a:t>Jul 2026</a:t>
             </a:r>
           </a:p>
         </p:txBody>
@@ -3214,7 +3214,7 @@
         </p:nvSpPr>
         <p:spPr>
           <a:xfrm>
-            <a:off x="9784080" y="1234440"/>
+            <a:off x="9784080" y="1170432"/>
             <a:ext cx="1280160" cy="256032"/>
           </a:xfrm>
           <a:prstGeom prst="rect">
@@ -3244,96 +3244,20 @@
       </p:sp>
       <p:sp>
         <p:nvSpPr>
-          <p:cNvPr id="6" name="TextBox 5"/>
-          <p:cNvSpPr txBox="1"/>
+          <p:cNvPr id="6" name="Rectangle 5"/>
+          <p:cNvSpPr/>
           <p:nvPr/>
         </p:nvSpPr>
         <p:spPr>
           <a:xfrm>
-            <a:off x="5692140" y="1234440"/>
-            <a:ext cx="914400" cy="256032"/>
+            <a:off x="1234440" y="1920240"/>
+            <a:ext cx="9829800" cy="164592"/>
           </a:xfrm>
           <a:prstGeom prst="rect">
             <a:avLst/>
           </a:prstGeom>
-          <a:noFill/>
-        </p:spPr>
-        <p:txBody>
-          <a:bodyPr wrap="square">
-            <a:spAutoFit/>
-          </a:bodyPr>
-          <a:lstStyle/>
-          <a:p>
-            <a:pPr algn="ctr">
-              <a:defRPr sz="900" b="0" i="0">
-                <a:solidFill>
-                  <a:srgbClr val="64748B"/>
-                </a:solidFill>
-                <a:latin typeface="Arial"/>
-              </a:defRPr>
-            </a:pPr>
-            <a:r>
-              <a:t>Jan 2027</a:t>
-            </a:r>
-          </a:p>
-        </p:txBody>
-      </p:sp>
-      <p:sp>
-        <p:nvSpPr>
-          <p:cNvPr id="7" name="TextBox 6"/>
-          <p:cNvSpPr txBox="1"/>
-          <p:nvPr/>
-        </p:nvSpPr>
-        <p:spPr>
-          <a:xfrm>
-            <a:off x="137160" y="1691640"/>
-            <a:ext cx="1005840" cy="457200"/>
-          </a:xfrm>
-          <a:prstGeom prst="rect">
-            <a:avLst/>
-          </a:prstGeom>
-          <a:noFill/>
-        </p:spPr>
-        <p:txBody>
-          <a:bodyPr wrap="square">
-            <a:spAutoFit/>
-          </a:bodyPr>
-          <a:lstStyle/>
-          <a:p>
-            <a:pPr algn="r">
-              <a:defRPr sz="900" b="1" i="0">
-                <a:solidFill>
-                  <a:srgbClr val="2E9E5B"/>
-                </a:solidFill>
-                <a:latin typeface="Arial"/>
-              </a:defRPr>
-            </a:pPr>
-            <a:r>
-              <a:t>New</a:t>
-            </a:r>
-            <a:br/>
-            <a:r>
-              <a:t>Users</a:t>
-            </a:r>
-          </a:p>
-        </p:txBody>
-      </p:sp>
-      <p:sp>
-        <p:nvSpPr>
-          <p:cNvPr id="8" name="Oval 7"/>
-          <p:cNvSpPr/>
-          <p:nvPr/>
-        </p:nvSpPr>
-        <p:spPr>
-          <a:xfrm>
-            <a:off x="2125391" y="1892808"/>
-            <a:ext cx="164592" cy="164592"/>
-          </a:xfrm>
-          <a:prstGeom prst="ellipse">
-            <a:avLst/>
-          </a:prstGeom>
           <a:solidFill>
-            <a:srgbClr val="2E9E5B"/>
+            <a:srgbClr val="D1D5DB"/>
           </a:solidFill>
           <a:ln>
             <a:noFill/>
@@ -3363,132 +3287,20 @@
       </p:sp>
       <p:sp>
         <p:nvSpPr>
-          <p:cNvPr id="9" name="TextBox 8"/>
-          <p:cNvSpPr txBox="1"/>
+          <p:cNvPr id="7" name="Rectangle 6"/>
+          <p:cNvSpPr/>
           <p:nvPr/>
         </p:nvSpPr>
         <p:spPr>
           <a:xfrm>
-            <a:off x="1704767" y="1618488"/>
-            <a:ext cx="1005840" cy="228600"/>
+            <a:off x="1234440" y="1920240"/>
+            <a:ext cx="2265604" cy="164592"/>
           </a:xfrm>
           <a:prstGeom prst="rect">
             <a:avLst/>
           </a:prstGeom>
-          <a:noFill/>
-        </p:spPr>
-        <p:txBody>
-          <a:bodyPr wrap="square">
-            <a:spAutoFit/>
-          </a:bodyPr>
-          <a:lstStyle/>
-          <a:p>
-            <a:pPr algn="ctr">
-              <a:defRPr sz="800" b="1" i="0">
-                <a:solidFill>
-                  <a:srgbClr val="2E9E5B"/>
-                </a:solidFill>
-                <a:latin typeface="Arial"/>
-              </a:defRPr>
-            </a:pPr>
-            <a:r>
-              <a:t>Early Q3</a:t>
-            </a:r>
-          </a:p>
-        </p:txBody>
-      </p:sp>
-      <p:sp>
-        <p:nvSpPr>
-          <p:cNvPr id="10" name="TextBox 9"/>
-          <p:cNvSpPr txBox="1"/>
-          <p:nvPr/>
-        </p:nvSpPr>
-        <p:spPr>
-          <a:xfrm>
-            <a:off x="1293287" y="2103120"/>
-            <a:ext cx="1828800" cy="502920"/>
-          </a:xfrm>
-          <a:prstGeom prst="rect">
-            <a:avLst/>
-          </a:prstGeom>
-          <a:noFill/>
-        </p:spPr>
-        <p:txBody>
-          <a:bodyPr wrap="square">
-            <a:spAutoFit/>
-          </a:bodyPr>
-          <a:lstStyle/>
-          <a:p>
-            <a:pPr algn="ctr">
-              <a:defRPr sz="800" b="0" i="0">
-                <a:solidFill>
-                  <a:srgbClr val="1E293B"/>
-                </a:solidFill>
-                <a:latin typeface="Arial"/>
-              </a:defRPr>
-            </a:pPr>
-            <a:r>
-              <a:t>Block API usage by registration date</a:t>
-            </a:r>
-          </a:p>
-        </p:txBody>
-      </p:sp>
-      <p:sp>
-        <p:nvSpPr>
-          <p:cNvPr id="11" name="TextBox 10"/>
-          <p:cNvSpPr txBox="1"/>
-          <p:nvPr/>
-        </p:nvSpPr>
-        <p:spPr>
-          <a:xfrm>
-            <a:off x="137160" y="2788920"/>
-            <a:ext cx="1005840" cy="457200"/>
-          </a:xfrm>
-          <a:prstGeom prst="rect">
-            <a:avLst/>
-          </a:prstGeom>
-          <a:noFill/>
-        </p:spPr>
-        <p:txBody>
-          <a:bodyPr wrap="square">
-            <a:spAutoFit/>
-          </a:bodyPr>
-          <a:lstStyle/>
-          <a:p>
-            <a:pPr algn="r">
-              <a:defRPr sz="900" b="1" i="0">
-                <a:solidFill>
-                  <a:srgbClr val="1B4F8A"/>
-                </a:solidFill>
-                <a:latin typeface="Arial"/>
-              </a:defRPr>
-            </a:pPr>
-            <a:r>
-              <a:t>Existing</a:t>
-            </a:r>
-            <a:br/>
-            <a:r>
-              <a:t>Users</a:t>
-            </a:r>
-          </a:p>
-        </p:txBody>
-      </p:sp>
-      <p:sp>
-        <p:nvSpPr>
-          <p:cNvPr id="12" name="Oval 11"/>
-          <p:cNvSpPr/>
-          <p:nvPr/>
-        </p:nvSpPr>
-        <p:spPr>
-          <a:xfrm>
-            <a:off x="4136769" y="2990088"/>
-            <a:ext cx="164592" cy="164592"/>
-          </a:xfrm>
-          <a:prstGeom prst="ellipse">
-            <a:avLst/>
-          </a:prstGeom>
           <a:solidFill>
-            <a:srgbClr val="1B4F8A"/>
+            <a:srgbClr val="2E9E5B"/>
           </a:solidFill>
           <a:ln>
             <a:noFill/>
@@ -3518,88 +3330,16 @@
       </p:sp>
       <p:sp>
         <p:nvSpPr>
-          <p:cNvPr id="13" name="TextBox 12"/>
-          <p:cNvSpPr txBox="1"/>
-          <p:nvPr/>
-        </p:nvSpPr>
-        <p:spPr>
-          <a:xfrm>
-            <a:off x="3716145" y="2715768"/>
-            <a:ext cx="1005840" cy="228600"/>
-          </a:xfrm>
-          <a:prstGeom prst="rect">
-            <a:avLst/>
-          </a:prstGeom>
-          <a:noFill/>
-        </p:spPr>
-        <p:txBody>
-          <a:bodyPr wrap="square">
-            <a:spAutoFit/>
-          </a:bodyPr>
-          <a:lstStyle/>
-          <a:p>
-            <a:pPr algn="ctr">
-              <a:defRPr sz="800" b="1" i="0">
-                <a:solidFill>
-                  <a:srgbClr val="1B4F8A"/>
-                </a:solidFill>
-                <a:latin typeface="Arial"/>
-              </a:defRPr>
-            </a:pPr>
-            <a:r>
-              <a:t>Beginning of Sept</a:t>
-            </a:r>
-          </a:p>
-        </p:txBody>
-      </p:sp>
-      <p:sp>
-        <p:nvSpPr>
-          <p:cNvPr id="14" name="TextBox 13"/>
-          <p:cNvSpPr txBox="1"/>
-          <p:nvPr/>
-        </p:nvSpPr>
-        <p:spPr>
-          <a:xfrm>
-            <a:off x="3304665" y="3200400"/>
-            <a:ext cx="1828800" cy="502920"/>
-          </a:xfrm>
-          <a:prstGeom prst="rect">
-            <a:avLst/>
-          </a:prstGeom>
-          <a:noFill/>
-        </p:spPr>
-        <p:txBody>
-          <a:bodyPr wrap="square">
-            <a:spAutoFit/>
-          </a:bodyPr>
-          <a:lstStyle/>
-          <a:p>
-            <a:pPr algn="ctr">
-              <a:defRPr sz="800" b="0" i="0">
-                <a:solidFill>
-                  <a:srgbClr val="1E293B"/>
-                </a:solidFill>
-                <a:latin typeface="Arial"/>
-              </a:defRPr>
-            </a:pPr>
-            <a:r>
-              <a:t>Automated email to migrated users</a:t>
-            </a:r>
-          </a:p>
-        </p:txBody>
-      </p:sp>
-      <p:sp>
-        <p:nvSpPr>
-          <p:cNvPr id="15" name="Oval 14"/>
+          <p:cNvPr id="8" name="Rectangle 7"/>
           <p:cNvSpPr/>
           <p:nvPr/>
         </p:nvSpPr>
         <p:spPr>
           <a:xfrm>
-            <a:off x="4818043" y="2990088"/>
-            <a:ext cx="164592" cy="164592"/>
-          </a:xfrm>
-          <a:prstGeom prst="ellipse">
+            <a:off x="3500044" y="1920240"/>
+            <a:ext cx="7564196" cy="164592"/>
+          </a:xfrm>
+          <a:prstGeom prst="rect">
             <a:avLst/>
           </a:prstGeom>
           <a:solidFill>
@@ -3633,14 +3373,14 @@
       </p:sp>
       <p:sp>
         <p:nvSpPr>
-          <p:cNvPr id="16" name="TextBox 15"/>
+          <p:cNvPr id="9" name="TextBox 8"/>
           <p:cNvSpPr txBox="1"/>
           <p:nvPr/>
         </p:nvSpPr>
         <p:spPr>
           <a:xfrm>
-            <a:off x="4397419" y="2715768"/>
-            <a:ext cx="1005840" cy="228600"/>
+            <a:off x="137160" y="1737360"/>
+            <a:ext cx="1005840" cy="411480"/>
           </a:xfrm>
           <a:prstGeom prst="rect">
             <a:avLst/>
@@ -3653,44 +3393,8 @@
           </a:bodyPr>
           <a:lstStyle/>
           <a:p>
-            <a:pPr algn="ctr">
-              <a:defRPr sz="800" b="1" i="0">
-                <a:solidFill>
-                  <a:srgbClr val="1B4F8A"/>
-                </a:solidFill>
-                <a:latin typeface="Arial"/>
-              </a:defRPr>
-            </a:pPr>
-            <a:r>
-              <a:t>End of September</a:t>
-            </a:r>
-          </a:p>
-        </p:txBody>
-      </p:sp>
-      <p:sp>
-        <p:nvSpPr>
-          <p:cNvPr id="17" name="TextBox 16"/>
-          <p:cNvSpPr txBox="1"/>
-          <p:nvPr/>
-        </p:nvSpPr>
-        <p:spPr>
-          <a:xfrm>
-            <a:off x="3985939" y="3200400"/>
-            <a:ext cx="1828800" cy="502920"/>
-          </a:xfrm>
-          <a:prstGeom prst="rect">
-            <a:avLst/>
-          </a:prstGeom>
-          <a:noFill/>
-        </p:spPr>
-        <p:txBody>
-          <a:bodyPr wrap="square">
-            <a:spAutoFit/>
-          </a:bodyPr>
-          <a:lstStyle/>
-          <a:p>
-            <a:pPr algn="ctr">
-              <a:defRPr sz="800" b="0" i="0">
+            <a:pPr algn="r">
+              <a:defRPr sz="900" b="1" i="0">
                 <a:solidFill>
                   <a:srgbClr val="1E293B"/>
                 </a:solidFill>
@@ -3698,30 +3402,36 @@
               </a:defRPr>
             </a:pPr>
             <a:r>
-              <a:t>Communication to all users</a:t>
-            </a:r>
-          </a:p>
-        </p:txBody>
-      </p:sp>
-      <p:sp>
-        <p:nvSpPr>
-          <p:cNvPr id="18" name="Oval 17"/>
+              <a:t>Open API</a:t>
+            </a:r>
+            <a:br/>
+            <a:r>
+              <a:t>Milestones</a:t>
+            </a:r>
+          </a:p>
+        </p:txBody>
+      </p:sp>
+      <p:sp>
+        <p:nvSpPr>
+          <p:cNvPr id="10" name="Oval 9"/>
           <p:cNvSpPr/>
           <p:nvPr/>
         </p:nvSpPr>
         <p:spPr>
           <a:xfrm>
-            <a:off x="10852177" y="2990088"/>
-            <a:ext cx="164592" cy="164592"/>
+            <a:off x="1143000" y="1883664"/>
+            <a:ext cx="182880" cy="182880"/>
           </a:xfrm>
           <a:prstGeom prst="ellipse">
             <a:avLst/>
           </a:prstGeom>
           <a:solidFill>
-            <a:srgbClr val="1B4F8A"/>
+            <a:srgbClr val="2E9E5B"/>
           </a:solidFill>
-          <a:ln>
-            <a:noFill/>
+          <a:ln w="25400">
+            <a:solidFill>
+              <a:srgbClr val="FFFFFF"/>
+            </a:solidFill>
           </a:ln>
         </p:spPr>
         <p:style>
@@ -3748,14 +3458,14 @@
       </p:sp>
       <p:sp>
         <p:nvSpPr>
-          <p:cNvPr id="19" name="TextBox 18"/>
+          <p:cNvPr id="11" name="TextBox 10"/>
           <p:cNvSpPr txBox="1"/>
           <p:nvPr/>
         </p:nvSpPr>
         <p:spPr>
           <a:xfrm>
-            <a:off x="10431553" y="2715768"/>
-            <a:ext cx="1005840" cy="228600"/>
+            <a:off x="640080" y="1371600"/>
+            <a:ext cx="1188720" cy="256032"/>
           </a:xfrm>
           <a:prstGeom prst="rect">
             <a:avLst/>
@@ -3769,65 +3479,29 @@
           <a:lstStyle/>
           <a:p>
             <a:pPr algn="ctr">
-              <a:defRPr sz="800" b="1" i="0">
+              <a:defRPr sz="900" b="1" i="0">
                 <a:solidFill>
-                  <a:srgbClr val="1B4F8A"/>
+                  <a:srgbClr val="2E9E5B"/>
                 </a:solidFill>
                 <a:latin typeface="Arial"/>
               </a:defRPr>
             </a:pPr>
             <a:r>
-              <a:t>EO March 27</a:t>
-            </a:r>
-          </a:p>
-        </p:txBody>
-      </p:sp>
-      <p:sp>
-        <p:nvSpPr>
-          <p:cNvPr id="20" name="TextBox 19"/>
-          <p:cNvSpPr txBox="1"/>
-          <p:nvPr/>
-        </p:nvSpPr>
-        <p:spPr>
-          <a:xfrm>
-            <a:off x="10020073" y="3200400"/>
-            <a:ext cx="1828800" cy="502920"/>
-          </a:xfrm>
-          <a:prstGeom prst="rect">
-            <a:avLst/>
-          </a:prstGeom>
-          <a:noFill/>
-        </p:spPr>
-        <p:txBody>
-          <a:bodyPr wrap="square">
-            <a:spAutoFit/>
-          </a:bodyPr>
-          <a:lstStyle/>
-          <a:p>
-            <a:pPr algn="ctr">
-              <a:defRPr sz="800" b="0" i="0">
-                <a:solidFill>
-                  <a:srgbClr val="1E293B"/>
-                </a:solidFill>
-                <a:latin typeface="Arial"/>
-              </a:defRPr>
-            </a:pPr>
-            <a:r>
-              <a:t>Deprecation of old Open API (OAPI)</a:t>
-            </a:r>
-          </a:p>
-        </p:txBody>
-      </p:sp>
-      <p:sp>
-        <p:nvSpPr>
-          <p:cNvPr id="21" name="Rounded Rectangle 20"/>
+              <a:t>Early Q3</a:t>
+            </a:r>
+          </a:p>
+        </p:txBody>
+      </p:sp>
+      <p:sp>
+        <p:nvSpPr>
+          <p:cNvPr id="12" name="Rounded Rectangle 11"/>
           <p:cNvSpPr/>
           <p:nvPr/>
         </p:nvSpPr>
         <p:spPr>
           <a:xfrm>
-            <a:off x="731520" y="4434840"/>
-            <a:ext cx="5303520" cy="1234440"/>
+            <a:off x="68580" y="1463040"/>
+            <a:ext cx="2331720" cy="868680"/>
           </a:xfrm>
           <a:prstGeom prst="roundRect">
             <a:avLst>
@@ -3867,14 +3541,14 @@
       </p:sp>
       <p:sp>
         <p:nvSpPr>
-          <p:cNvPr id="22" name="TextBox 21"/>
+          <p:cNvPr id="13" name="TextBox 12"/>
           <p:cNvSpPr txBox="1"/>
           <p:nvPr/>
         </p:nvSpPr>
         <p:spPr>
           <a:xfrm>
-            <a:off x="914400" y="4572000"/>
-            <a:ext cx="4937760" cy="274320"/>
+            <a:off x="160020" y="1517904"/>
+            <a:ext cx="2148840" cy="201168"/>
           </a:xfrm>
           <a:prstGeom prst="rect">
             <a:avLst/>
@@ -3887,8 +3561,8 @@
           </a:bodyPr>
           <a:lstStyle/>
           <a:p>
-            <a:pPr algn="l">
-              <a:defRPr sz="1200" b="1" i="0">
+            <a:pPr algn="ctr">
+              <a:defRPr sz="700" b="1" i="0">
                 <a:solidFill>
                   <a:srgbClr val="2E9E5B"/>
                 </a:solidFill>
@@ -3903,14 +3577,14 @@
       </p:sp>
       <p:sp>
         <p:nvSpPr>
-          <p:cNvPr id="23" name="TextBox 22"/>
+          <p:cNvPr id="14" name="TextBox 13"/>
           <p:cNvSpPr txBox="1"/>
           <p:nvPr/>
         </p:nvSpPr>
         <p:spPr>
           <a:xfrm>
-            <a:off x="914400" y="4892040"/>
-            <a:ext cx="4937760" cy="640080"/>
+            <a:off x="160020" y="1719072"/>
+            <a:ext cx="2148840" cy="320040"/>
           </a:xfrm>
           <a:prstGeom prst="rect">
             <a:avLst/>
@@ -3923,8 +3597,8 @@
           </a:bodyPr>
           <a:lstStyle/>
           <a:p>
-            <a:pPr algn="l">
-              <a:defRPr sz="1000" b="0" i="0">
+            <a:pPr algn="ctr">
+              <a:defRPr sz="800" b="1" i="0">
                 <a:solidFill>
                   <a:srgbClr val="1E293B"/>
                 </a:solidFill>
@@ -3932,33 +3606,67 @@
               </a:defRPr>
             </a:pPr>
             <a:r>
-              <a:t>Early Q3 — Block API by registration date</a:t>
-            </a:r>
-          </a:p>
-        </p:txBody>
-      </p:sp>
-      <p:sp>
-        <p:nvSpPr>
-          <p:cNvPr id="24" name="Rounded Rectangle 23"/>
+              <a:t>Block API usage by registration date</a:t>
+            </a:r>
+          </a:p>
+        </p:txBody>
+      </p:sp>
+      <p:sp>
+        <p:nvSpPr>
+          <p:cNvPr id="15" name="TextBox 14"/>
+          <p:cNvSpPr txBox="1"/>
+          <p:nvPr/>
+        </p:nvSpPr>
+        <p:spPr>
+          <a:xfrm>
+            <a:off x="160020" y="2029968"/>
+            <a:ext cx="2148840" cy="274320"/>
+          </a:xfrm>
+          <a:prstGeom prst="rect">
+            <a:avLst/>
+          </a:prstGeom>
+          <a:noFill/>
+        </p:spPr>
+        <p:txBody>
+          <a:bodyPr wrap="square">
+            <a:spAutoFit/>
+          </a:bodyPr>
+          <a:lstStyle/>
+          <a:p>
+            <a:pPr algn="ctr">
+              <a:defRPr sz="700" b="0" i="1">
+                <a:solidFill>
+                  <a:srgbClr val="64748B"/>
+                </a:solidFill>
+                <a:latin typeface="Arial"/>
+              </a:defRPr>
+            </a:pPr>
+            <a:r>
+              <a:t>By registration date, block API usage for new users</a:t>
+            </a:r>
+          </a:p>
+        </p:txBody>
+      </p:sp>
+      <p:sp>
+        <p:nvSpPr>
+          <p:cNvPr id="16" name="Oval 15"/>
           <p:cNvSpPr/>
           <p:nvPr/>
         </p:nvSpPr>
         <p:spPr>
           <a:xfrm>
-            <a:off x="6400800" y="4434840"/>
-            <a:ext cx="5303520" cy="1234440"/>
-          </a:xfrm>
-          <a:prstGeom prst="roundRect">
-            <a:avLst>
-              <a:gd name="adj" fmla="val 6000"/>
-            </a:avLst>
+            <a:off x="3408604" y="1883664"/>
+            <a:ext cx="182880" cy="182880"/>
+          </a:xfrm>
+          <a:prstGeom prst="ellipse">
+            <a:avLst/>
           </a:prstGeom>
           <a:solidFill>
-            <a:srgbClr val="FFFFFF"/>
+            <a:srgbClr val="1B4F8A"/>
           </a:solidFill>
-          <a:ln w="19050">
+          <a:ln w="25400">
             <a:solidFill>
-              <a:srgbClr val="1B4F8A"/>
+              <a:srgbClr val="FFFFFF"/>
             </a:solidFill>
           </a:ln>
         </p:spPr>
@@ -3986,14 +3694,14 @@
       </p:sp>
       <p:sp>
         <p:nvSpPr>
-          <p:cNvPr id="25" name="TextBox 24"/>
+          <p:cNvPr id="17" name="TextBox 16"/>
           <p:cNvSpPr txBox="1"/>
           <p:nvPr/>
         </p:nvSpPr>
         <p:spPr>
           <a:xfrm>
-            <a:off x="6583680" y="4572000"/>
-            <a:ext cx="4937760" cy="274320"/>
+            <a:off x="2905684" y="2240280"/>
+            <a:ext cx="1188720" cy="256032"/>
           </a:xfrm>
           <a:prstGeom prst="rect">
             <a:avLst/>
@@ -4006,8 +3714,8 @@
           </a:bodyPr>
           <a:lstStyle/>
           <a:p>
-            <a:pPr algn="l">
-              <a:defRPr sz="1200" b="1" i="0">
+            <a:pPr algn="ctr">
+              <a:defRPr sz="900" b="1" i="0">
                 <a:solidFill>
                   <a:srgbClr val="1B4F8A"/>
                 </a:solidFill>
@@ -4015,6 +3723,325 @@
               </a:defRPr>
             </a:pPr>
             <a:r>
+              <a:t>Beginning of Sept</a:t>
+            </a:r>
+          </a:p>
+        </p:txBody>
+      </p:sp>
+      <p:sp>
+        <p:nvSpPr>
+          <p:cNvPr id="18" name="Rounded Rectangle 17"/>
+          <p:cNvSpPr/>
+          <p:nvPr/>
+        </p:nvSpPr>
+        <p:spPr>
+          <a:xfrm>
+            <a:off x="2334184" y="2423160"/>
+            <a:ext cx="2331720" cy="868680"/>
+          </a:xfrm>
+          <a:prstGeom prst="roundRect">
+            <a:avLst>
+              <a:gd name="adj" fmla="val 6000"/>
+            </a:avLst>
+          </a:prstGeom>
+          <a:solidFill>
+            <a:srgbClr val="FFFFFF"/>
+          </a:solidFill>
+          <a:ln w="19050">
+            <a:solidFill>
+              <a:srgbClr val="1B4F8A"/>
+            </a:solidFill>
+          </a:ln>
+        </p:spPr>
+        <p:style>
+          <a:lnRef idx="1">
+            <a:schemeClr val="accent1"/>
+          </a:lnRef>
+          <a:fillRef idx="3">
+            <a:schemeClr val="accent1"/>
+          </a:fillRef>
+          <a:effectRef idx="2">
+            <a:schemeClr val="accent1"/>
+          </a:effectRef>
+          <a:fontRef idx="minor">
+            <a:schemeClr val="lt1"/>
+          </a:fontRef>
+        </p:style>
+        <p:txBody>
+          <a:bodyPr rtlCol="0" anchor="ctr"/>
+          <a:lstStyle/>
+          <a:p>
+            <a:pPr algn="ctr"/>
+          </a:p>
+        </p:txBody>
+      </p:sp>
+      <p:sp>
+        <p:nvSpPr>
+          <p:cNvPr id="19" name="TextBox 18"/>
+          <p:cNvSpPr txBox="1"/>
+          <p:nvPr/>
+        </p:nvSpPr>
+        <p:spPr>
+          <a:xfrm>
+            <a:off x="2425624" y="2478024"/>
+            <a:ext cx="2148840" cy="201168"/>
+          </a:xfrm>
+          <a:prstGeom prst="rect">
+            <a:avLst/>
+          </a:prstGeom>
+          <a:noFill/>
+        </p:spPr>
+        <p:txBody>
+          <a:bodyPr wrap="square">
+            <a:spAutoFit/>
+          </a:bodyPr>
+          <a:lstStyle/>
+          <a:p>
+            <a:pPr algn="ctr">
+              <a:defRPr sz="700" b="1" i="0">
+                <a:solidFill>
+                  <a:srgbClr val="1B4F8A"/>
+                </a:solidFill>
+                <a:latin typeface="Arial"/>
+              </a:defRPr>
+            </a:pPr>
+            <a:r>
+              <a:t>Existing Users</a:t>
+            </a:r>
+          </a:p>
+        </p:txBody>
+      </p:sp>
+      <p:sp>
+        <p:nvSpPr>
+          <p:cNvPr id="20" name="TextBox 19"/>
+          <p:cNvSpPr txBox="1"/>
+          <p:nvPr/>
+        </p:nvSpPr>
+        <p:spPr>
+          <a:xfrm>
+            <a:off x="2425624" y="2679192"/>
+            <a:ext cx="2148840" cy="320040"/>
+          </a:xfrm>
+          <a:prstGeom prst="rect">
+            <a:avLst/>
+          </a:prstGeom>
+          <a:noFill/>
+        </p:spPr>
+        <p:txBody>
+          <a:bodyPr wrap="square">
+            <a:spAutoFit/>
+          </a:bodyPr>
+          <a:lstStyle/>
+          <a:p>
+            <a:pPr algn="ctr">
+              <a:defRPr sz="800" b="1" i="0">
+                <a:solidFill>
+                  <a:srgbClr val="1E293B"/>
+                </a:solidFill>
+                <a:latin typeface="Arial"/>
+              </a:defRPr>
+            </a:pPr>
+            <a:r>
+              <a:t>Automated email to migrated users</a:t>
+            </a:r>
+          </a:p>
+        </p:txBody>
+      </p:sp>
+      <p:sp>
+        <p:nvSpPr>
+          <p:cNvPr id="21" name="TextBox 20"/>
+          <p:cNvSpPr txBox="1"/>
+          <p:nvPr/>
+        </p:nvSpPr>
+        <p:spPr>
+          <a:xfrm>
+            <a:off x="2425624" y="2990088"/>
+            <a:ext cx="2148840" cy="274320"/>
+          </a:xfrm>
+          <a:prstGeom prst="rect">
+            <a:avLst/>
+          </a:prstGeom>
+          <a:noFill/>
+        </p:spPr>
+        <p:txBody>
+          <a:bodyPr wrap="square">
+            <a:spAutoFit/>
+          </a:bodyPr>
+          <a:lstStyle/>
+          <a:p>
+            <a:pPr algn="ctr">
+              <a:defRPr sz="700" b="0" i="1">
+                <a:solidFill>
+                  <a:srgbClr val="64748B"/>
+                </a:solidFill>
+                <a:latin typeface="Arial"/>
+              </a:defRPr>
+            </a:pPr>
+            <a:r>
+              <a:t>Start sending automated email to migrated users</a:t>
+            </a:r>
+          </a:p>
+        </p:txBody>
+      </p:sp>
+      <p:sp>
+        <p:nvSpPr>
+          <p:cNvPr id="22" name="Oval 21"/>
+          <p:cNvSpPr/>
+          <p:nvPr/>
+        </p:nvSpPr>
+        <p:spPr>
+          <a:xfrm>
+            <a:off x="4175986" y="1883664"/>
+            <a:ext cx="182880" cy="182880"/>
+          </a:xfrm>
+          <a:prstGeom prst="ellipse">
+            <a:avLst/>
+          </a:prstGeom>
+          <a:solidFill>
+            <a:srgbClr val="1B4F8A"/>
+          </a:solidFill>
+          <a:ln w="25400">
+            <a:solidFill>
+              <a:srgbClr val="FFFFFF"/>
+            </a:solidFill>
+          </a:ln>
+        </p:spPr>
+        <p:style>
+          <a:lnRef idx="1">
+            <a:schemeClr val="accent1"/>
+          </a:lnRef>
+          <a:fillRef idx="3">
+            <a:schemeClr val="accent1"/>
+          </a:fillRef>
+          <a:effectRef idx="2">
+            <a:schemeClr val="accent1"/>
+          </a:effectRef>
+          <a:fontRef idx="minor">
+            <a:schemeClr val="lt1"/>
+          </a:fontRef>
+        </p:style>
+        <p:txBody>
+          <a:bodyPr rtlCol="0" anchor="ctr"/>
+          <a:lstStyle/>
+          <a:p>
+            <a:pPr algn="ctr"/>
+          </a:p>
+        </p:txBody>
+      </p:sp>
+      <p:sp>
+        <p:nvSpPr>
+          <p:cNvPr id="23" name="TextBox 22"/>
+          <p:cNvSpPr txBox="1"/>
+          <p:nvPr/>
+        </p:nvSpPr>
+        <p:spPr>
+          <a:xfrm>
+            <a:off x="3673066" y="1371600"/>
+            <a:ext cx="1188720" cy="256032"/>
+          </a:xfrm>
+          <a:prstGeom prst="rect">
+            <a:avLst/>
+          </a:prstGeom>
+          <a:noFill/>
+        </p:spPr>
+        <p:txBody>
+          <a:bodyPr wrap="square">
+            <a:spAutoFit/>
+          </a:bodyPr>
+          <a:lstStyle/>
+          <a:p>
+            <a:pPr algn="ctr">
+              <a:defRPr sz="900" b="1" i="0">
+                <a:solidFill>
+                  <a:srgbClr val="1B4F8A"/>
+                </a:solidFill>
+                <a:latin typeface="Arial"/>
+              </a:defRPr>
+            </a:pPr>
+            <a:r>
+              <a:t>End of September</a:t>
+            </a:r>
+          </a:p>
+        </p:txBody>
+      </p:sp>
+      <p:sp>
+        <p:nvSpPr>
+          <p:cNvPr id="24" name="Rounded Rectangle 23"/>
+          <p:cNvSpPr/>
+          <p:nvPr/>
+        </p:nvSpPr>
+        <p:spPr>
+          <a:xfrm>
+            <a:off x="3101566" y="1463040"/>
+            <a:ext cx="2331720" cy="868680"/>
+          </a:xfrm>
+          <a:prstGeom prst="roundRect">
+            <a:avLst>
+              <a:gd name="adj" fmla="val 6000"/>
+            </a:avLst>
+          </a:prstGeom>
+          <a:solidFill>
+            <a:srgbClr val="FFFFFF"/>
+          </a:solidFill>
+          <a:ln w="19050">
+            <a:solidFill>
+              <a:srgbClr val="1B4F8A"/>
+            </a:solidFill>
+          </a:ln>
+        </p:spPr>
+        <p:style>
+          <a:lnRef idx="1">
+            <a:schemeClr val="accent1"/>
+          </a:lnRef>
+          <a:fillRef idx="3">
+            <a:schemeClr val="accent1"/>
+          </a:fillRef>
+          <a:effectRef idx="2">
+            <a:schemeClr val="accent1"/>
+          </a:effectRef>
+          <a:fontRef idx="minor">
+            <a:schemeClr val="lt1"/>
+          </a:fontRef>
+        </p:style>
+        <p:txBody>
+          <a:bodyPr rtlCol="0" anchor="ctr"/>
+          <a:lstStyle/>
+          <a:p>
+            <a:pPr algn="ctr"/>
+          </a:p>
+        </p:txBody>
+      </p:sp>
+      <p:sp>
+        <p:nvSpPr>
+          <p:cNvPr id="25" name="TextBox 24"/>
+          <p:cNvSpPr txBox="1"/>
+          <p:nvPr/>
+        </p:nvSpPr>
+        <p:spPr>
+          <a:xfrm>
+            <a:off x="3193006" y="1517904"/>
+            <a:ext cx="2148840" cy="201168"/>
+          </a:xfrm>
+          <a:prstGeom prst="rect">
+            <a:avLst/>
+          </a:prstGeom>
+          <a:noFill/>
+        </p:spPr>
+        <p:txBody>
+          <a:bodyPr wrap="square">
+            <a:spAutoFit/>
+          </a:bodyPr>
+          <a:lstStyle/>
+          <a:p>
+            <a:pPr algn="ctr">
+              <a:defRPr sz="700" b="1" i="0">
+                <a:solidFill>
+                  <a:srgbClr val="1B4F8A"/>
+                </a:solidFill>
+                <a:latin typeface="Arial"/>
+              </a:defRPr>
+            </a:pPr>
+            <a:r>
               <a:t>Existing Users</a:t>
             </a:r>
           </a:p>
@@ -4028,8 +4055,359 @@
         </p:nvSpPr>
         <p:spPr>
           <a:xfrm>
-            <a:off x="6583680" y="4892040"/>
-            <a:ext cx="4937760" cy="640080"/>
+            <a:off x="3193006" y="1719072"/>
+            <a:ext cx="2148840" cy="320040"/>
+          </a:xfrm>
+          <a:prstGeom prst="rect">
+            <a:avLst/>
+          </a:prstGeom>
+          <a:noFill/>
+        </p:spPr>
+        <p:txBody>
+          <a:bodyPr wrap="square">
+            <a:spAutoFit/>
+          </a:bodyPr>
+          <a:lstStyle/>
+          <a:p>
+            <a:pPr algn="ctr">
+              <a:defRPr sz="800" b="1" i="0">
+                <a:solidFill>
+                  <a:srgbClr val="1E293B"/>
+                </a:solidFill>
+                <a:latin typeface="Arial"/>
+              </a:defRPr>
+            </a:pPr>
+            <a:r>
+              <a:t>Communication to all users</a:t>
+            </a:r>
+          </a:p>
+        </p:txBody>
+      </p:sp>
+      <p:sp>
+        <p:nvSpPr>
+          <p:cNvPr id="27" name="TextBox 26"/>
+          <p:cNvSpPr txBox="1"/>
+          <p:nvPr/>
+        </p:nvSpPr>
+        <p:spPr>
+          <a:xfrm>
+            <a:off x="3193006" y="2029968"/>
+            <a:ext cx="2148840" cy="274320"/>
+          </a:xfrm>
+          <a:prstGeom prst="rect">
+            <a:avLst/>
+          </a:prstGeom>
+          <a:noFill/>
+        </p:spPr>
+        <p:txBody>
+          <a:bodyPr wrap="square">
+            <a:spAutoFit/>
+          </a:bodyPr>
+          <a:lstStyle/>
+          <a:p>
+            <a:pPr algn="ctr">
+              <a:defRPr sz="700" b="0" i="1">
+                <a:solidFill>
+                  <a:srgbClr val="64748B"/>
+                </a:solidFill>
+                <a:latin typeface="Arial"/>
+              </a:defRPr>
+            </a:pPr>
+            <a:r>
+              <a:t>Sending communication to all users</a:t>
+            </a:r>
+          </a:p>
+        </p:txBody>
+      </p:sp>
+      <p:sp>
+        <p:nvSpPr>
+          <p:cNvPr id="28" name="Oval 27"/>
+          <p:cNvSpPr/>
+          <p:nvPr/>
+        </p:nvSpPr>
+        <p:spPr>
+          <a:xfrm>
+            <a:off x="10972800" y="1883664"/>
+            <a:ext cx="182880" cy="182880"/>
+          </a:xfrm>
+          <a:prstGeom prst="ellipse">
+            <a:avLst/>
+          </a:prstGeom>
+          <a:solidFill>
+            <a:srgbClr val="1B4F8A"/>
+          </a:solidFill>
+          <a:ln w="25400">
+            <a:solidFill>
+              <a:srgbClr val="FFFFFF"/>
+            </a:solidFill>
+          </a:ln>
+        </p:spPr>
+        <p:style>
+          <a:lnRef idx="1">
+            <a:schemeClr val="accent1"/>
+          </a:lnRef>
+          <a:fillRef idx="3">
+            <a:schemeClr val="accent1"/>
+          </a:fillRef>
+          <a:effectRef idx="2">
+            <a:schemeClr val="accent1"/>
+          </a:effectRef>
+          <a:fontRef idx="minor">
+            <a:schemeClr val="lt1"/>
+          </a:fontRef>
+        </p:style>
+        <p:txBody>
+          <a:bodyPr rtlCol="0" anchor="ctr"/>
+          <a:lstStyle/>
+          <a:p>
+            <a:pPr algn="ctr"/>
+          </a:p>
+        </p:txBody>
+      </p:sp>
+      <p:sp>
+        <p:nvSpPr>
+          <p:cNvPr id="29" name="TextBox 28"/>
+          <p:cNvSpPr txBox="1"/>
+          <p:nvPr/>
+        </p:nvSpPr>
+        <p:spPr>
+          <a:xfrm>
+            <a:off x="10469880" y="2240280"/>
+            <a:ext cx="1188720" cy="256032"/>
+          </a:xfrm>
+          <a:prstGeom prst="rect">
+            <a:avLst/>
+          </a:prstGeom>
+          <a:noFill/>
+        </p:spPr>
+        <p:txBody>
+          <a:bodyPr wrap="square">
+            <a:spAutoFit/>
+          </a:bodyPr>
+          <a:lstStyle/>
+          <a:p>
+            <a:pPr algn="ctr">
+              <a:defRPr sz="900" b="1" i="0">
+                <a:solidFill>
+                  <a:srgbClr val="1B4F8A"/>
+                </a:solidFill>
+                <a:latin typeface="Arial"/>
+              </a:defRPr>
+            </a:pPr>
+            <a:r>
+              <a:t>EO March 27</a:t>
+            </a:r>
+          </a:p>
+        </p:txBody>
+      </p:sp>
+      <p:sp>
+        <p:nvSpPr>
+          <p:cNvPr id="30" name="Rounded Rectangle 29"/>
+          <p:cNvSpPr/>
+          <p:nvPr/>
+        </p:nvSpPr>
+        <p:spPr>
+          <a:xfrm>
+            <a:off x="9898380" y="2423160"/>
+            <a:ext cx="2331720" cy="868680"/>
+          </a:xfrm>
+          <a:prstGeom prst="roundRect">
+            <a:avLst>
+              <a:gd name="adj" fmla="val 6000"/>
+            </a:avLst>
+          </a:prstGeom>
+          <a:solidFill>
+            <a:srgbClr val="FFFFFF"/>
+          </a:solidFill>
+          <a:ln w="19050">
+            <a:solidFill>
+              <a:srgbClr val="1B4F8A"/>
+            </a:solidFill>
+          </a:ln>
+        </p:spPr>
+        <p:style>
+          <a:lnRef idx="1">
+            <a:schemeClr val="accent1"/>
+          </a:lnRef>
+          <a:fillRef idx="3">
+            <a:schemeClr val="accent1"/>
+          </a:fillRef>
+          <a:effectRef idx="2">
+            <a:schemeClr val="accent1"/>
+          </a:effectRef>
+          <a:fontRef idx="minor">
+            <a:schemeClr val="lt1"/>
+          </a:fontRef>
+        </p:style>
+        <p:txBody>
+          <a:bodyPr rtlCol="0" anchor="ctr"/>
+          <a:lstStyle/>
+          <a:p>
+            <a:pPr algn="ctr"/>
+          </a:p>
+        </p:txBody>
+      </p:sp>
+      <p:sp>
+        <p:nvSpPr>
+          <p:cNvPr id="31" name="TextBox 30"/>
+          <p:cNvSpPr txBox="1"/>
+          <p:nvPr/>
+        </p:nvSpPr>
+        <p:spPr>
+          <a:xfrm>
+            <a:off x="9989820" y="2478024"/>
+            <a:ext cx="2148840" cy="201168"/>
+          </a:xfrm>
+          <a:prstGeom prst="rect">
+            <a:avLst/>
+          </a:prstGeom>
+          <a:noFill/>
+        </p:spPr>
+        <p:txBody>
+          <a:bodyPr wrap="square">
+            <a:spAutoFit/>
+          </a:bodyPr>
+          <a:lstStyle/>
+          <a:p>
+            <a:pPr algn="ctr">
+              <a:defRPr sz="700" b="1" i="0">
+                <a:solidFill>
+                  <a:srgbClr val="1B4F8A"/>
+                </a:solidFill>
+                <a:latin typeface="Arial"/>
+              </a:defRPr>
+            </a:pPr>
+            <a:r>
+              <a:t>Existing Users</a:t>
+            </a:r>
+          </a:p>
+        </p:txBody>
+      </p:sp>
+      <p:sp>
+        <p:nvSpPr>
+          <p:cNvPr id="32" name="TextBox 31"/>
+          <p:cNvSpPr txBox="1"/>
+          <p:nvPr/>
+        </p:nvSpPr>
+        <p:spPr>
+          <a:xfrm>
+            <a:off x="9989820" y="2679192"/>
+            <a:ext cx="2148840" cy="320040"/>
+          </a:xfrm>
+          <a:prstGeom prst="rect">
+            <a:avLst/>
+          </a:prstGeom>
+          <a:noFill/>
+        </p:spPr>
+        <p:txBody>
+          <a:bodyPr wrap="square">
+            <a:spAutoFit/>
+          </a:bodyPr>
+          <a:lstStyle/>
+          <a:p>
+            <a:pPr algn="ctr">
+              <a:defRPr sz="800" b="1" i="0">
+                <a:solidFill>
+                  <a:srgbClr val="1E293B"/>
+                </a:solidFill>
+                <a:latin typeface="Arial"/>
+              </a:defRPr>
+            </a:pPr>
+            <a:r>
+              <a:t>Deprecation of old Open API (OAPI)</a:t>
+            </a:r>
+          </a:p>
+        </p:txBody>
+      </p:sp>
+      <p:sp>
+        <p:nvSpPr>
+          <p:cNvPr id="33" name="TextBox 32"/>
+          <p:cNvSpPr txBox="1"/>
+          <p:nvPr/>
+        </p:nvSpPr>
+        <p:spPr>
+          <a:xfrm>
+            <a:off x="9989820" y="2990088"/>
+            <a:ext cx="2148840" cy="274320"/>
+          </a:xfrm>
+          <a:prstGeom prst="rect">
+            <a:avLst/>
+          </a:prstGeom>
+          <a:noFill/>
+        </p:spPr>
+        <p:txBody>
+          <a:bodyPr wrap="square">
+            <a:spAutoFit/>
+          </a:bodyPr>
+          <a:lstStyle/>
+          <a:p>
+            <a:pPr algn="ctr">
+              <a:defRPr sz="700" b="0" i="1">
+                <a:solidFill>
+                  <a:srgbClr val="64748B"/>
+                </a:solidFill>
+                <a:latin typeface="Arial"/>
+              </a:defRPr>
+            </a:pPr>
+            <a:r>
+              <a:t>End of deprecation period for old OAPI</a:t>
+            </a:r>
+          </a:p>
+        </p:txBody>
+      </p:sp>
+      <p:sp>
+        <p:nvSpPr>
+          <p:cNvPr id="34" name="Rectangle 33"/>
+          <p:cNvSpPr/>
+          <p:nvPr/>
+        </p:nvSpPr>
+        <p:spPr>
+          <a:xfrm>
+            <a:off x="4389120" y="5806440"/>
+            <a:ext cx="201168" cy="201168"/>
+          </a:xfrm>
+          <a:prstGeom prst="rect">
+            <a:avLst/>
+          </a:prstGeom>
+          <a:solidFill>
+            <a:srgbClr val="2E9E5B"/>
+          </a:solidFill>
+          <a:ln>
+            <a:noFill/>
+          </a:ln>
+        </p:spPr>
+        <p:style>
+          <a:lnRef idx="1">
+            <a:schemeClr val="accent1"/>
+          </a:lnRef>
+          <a:fillRef idx="3">
+            <a:schemeClr val="accent1"/>
+          </a:fillRef>
+          <a:effectRef idx="2">
+            <a:schemeClr val="accent1"/>
+          </a:effectRef>
+          <a:fontRef idx="minor">
+            <a:schemeClr val="lt1"/>
+          </a:fontRef>
+        </p:style>
+        <p:txBody>
+          <a:bodyPr rtlCol="0" anchor="ctr"/>
+          <a:lstStyle/>
+          <a:p>
+            <a:pPr algn="ctr"/>
+          </a:p>
+        </p:txBody>
+      </p:sp>
+      <p:sp>
+        <p:nvSpPr>
+          <p:cNvPr id="35" name="TextBox 34"/>
+          <p:cNvSpPr txBox="1"/>
+          <p:nvPr/>
+        </p:nvSpPr>
+        <p:spPr>
+          <a:xfrm>
+            <a:off x="4681728" y="5769864"/>
+            <a:ext cx="2011680" cy="274320"/>
           </a:xfrm>
           <a:prstGeom prst="rect">
             <a:avLst/>
@@ -4051,14 +4429,93 @@
               </a:defRPr>
             </a:pPr>
             <a:r>
-              <a:t>Sept emails → Sept comms → Mar 27 OAPI deprecation</a:t>
-            </a:r>
-          </a:p>
-        </p:txBody>
-      </p:sp>
-      <p:sp>
-        <p:nvSpPr>
-          <p:cNvPr id="27" name="TextBox 26"/>
+              <a:t>New Users</a:t>
+            </a:r>
+          </a:p>
+        </p:txBody>
+      </p:sp>
+      <p:sp>
+        <p:nvSpPr>
+          <p:cNvPr id="36" name="Rectangle 35"/>
+          <p:cNvSpPr/>
+          <p:nvPr/>
+        </p:nvSpPr>
+        <p:spPr>
+          <a:xfrm>
+            <a:off x="6949440" y="5806440"/>
+            <a:ext cx="201168" cy="201168"/>
+          </a:xfrm>
+          <a:prstGeom prst="rect">
+            <a:avLst/>
+          </a:prstGeom>
+          <a:solidFill>
+            <a:srgbClr val="1B4F8A"/>
+          </a:solidFill>
+          <a:ln>
+            <a:noFill/>
+          </a:ln>
+        </p:spPr>
+        <p:style>
+          <a:lnRef idx="1">
+            <a:schemeClr val="accent1"/>
+          </a:lnRef>
+          <a:fillRef idx="3">
+            <a:schemeClr val="accent1"/>
+          </a:fillRef>
+          <a:effectRef idx="2">
+            <a:schemeClr val="accent1"/>
+          </a:effectRef>
+          <a:fontRef idx="minor">
+            <a:schemeClr val="lt1"/>
+          </a:fontRef>
+        </p:style>
+        <p:txBody>
+          <a:bodyPr rtlCol="0" anchor="ctr"/>
+          <a:lstStyle/>
+          <a:p>
+            <a:pPr algn="ctr"/>
+          </a:p>
+        </p:txBody>
+      </p:sp>
+      <p:sp>
+        <p:nvSpPr>
+          <p:cNvPr id="37" name="TextBox 36"/>
+          <p:cNvSpPr txBox="1"/>
+          <p:nvPr/>
+        </p:nvSpPr>
+        <p:spPr>
+          <a:xfrm>
+            <a:off x="7242048" y="5769864"/>
+            <a:ext cx="2011680" cy="274320"/>
+          </a:xfrm>
+          <a:prstGeom prst="rect">
+            <a:avLst/>
+          </a:prstGeom>
+          <a:noFill/>
+        </p:spPr>
+        <p:txBody>
+          <a:bodyPr wrap="square">
+            <a:spAutoFit/>
+          </a:bodyPr>
+          <a:lstStyle/>
+          <a:p>
+            <a:pPr algn="l">
+              <a:defRPr sz="1000" b="0" i="0">
+                <a:solidFill>
+                  <a:srgbClr val="1E293B"/>
+                </a:solidFill>
+                <a:latin typeface="Arial"/>
+              </a:defRPr>
+            </a:pPr>
+            <a:r>
+              <a:t>Existing Users</a:t>
+            </a:r>
+          </a:p>
+        </p:txBody>
+      </p:sp>
+      <p:sp>
+        <p:nvSpPr>
+          <p:cNvPr id="38" name="TextBox 37"/>
           <p:cNvSpPr txBox="1"/>
           <p:nvPr/>
         </p:nvSpPr>

</xml_diff>